<commit_message>
Add keyword-data caveat to Mundo Tours Deck A
</commit_message>
<xml_diff>
--- a/deliverables/SOT-2041/mundo-tours-deck-a.pptx
+++ b/deliverables/SOT-2041/mundo-tours-deck-a.pptx
@@ -2349,8 +2349,8 @@
         </p:nvSpPr>
         <p:spPr>
           <a:xfrm>
-            <a:off x="502920" y="6492240"/>
-            <a:ext cx="3657600" cy="155448"/>
+            <a:off x="502920" y="6419088"/>
+            <a:ext cx="4389120" cy="256032"/>
           </a:xfrm>
           <a:prstGeom prst="rect">
             <a:avLst/>
@@ -2366,7 +2366,7 @@
               <a:buNone/>
             </a:pPr>
             <a:r>
-              <a:rPr lang="en-US" sz="800" b="1" spc="120" kern="0" dirty="0">
+              <a:rPr lang="en-US" sz="1200" b="1" spc="120" kern="0" dirty="0">
                 <a:solidFill>
                   <a:srgbClr val="B3B3FF"/>
                 </a:solidFill>
@@ -2376,7 +2376,7 @@
               </a:rPr>
               <a:t>SOTECH  /  MUNDO TOURS  /  A</a:t>
             </a:r>
-            <a:endParaRPr lang="en-US" sz="800" dirty="0"/>
+            <a:endParaRPr lang="en-US" sz="1200" dirty="0"/>
           </a:p>
         </p:txBody>
       </p:sp>
@@ -2388,8 +2388,8 @@
         </p:nvSpPr>
         <p:spPr>
           <a:xfrm>
-            <a:off x="11109960" y="6455664"/>
-            <a:ext cx="566928" cy="201168"/>
+            <a:off x="11018520" y="6419088"/>
+            <a:ext cx="658368" cy="256032"/>
           </a:xfrm>
           <a:prstGeom prst="rect">
             <a:avLst/>
@@ -2405,7 +2405,7 @@
               <a:buNone/>
             </a:pPr>
             <a:r>
-              <a:rPr lang="en-US" sz="900" b="1" dirty="0">
+              <a:rPr lang="en-US" sz="1200" b="1" dirty="0">
                 <a:solidFill>
                   <a:srgbClr val="B3B3FF"/>
                 </a:solidFill>
@@ -2415,7 +2415,7 @@
               </a:rPr>
               <a:t>01</a:t>
             </a:r>
-            <a:endParaRPr lang="en-US" sz="900" dirty="0"/>
+            <a:endParaRPr lang="en-US" sz="1200" dirty="0"/>
           </a:p>
         </p:txBody>
       </p:sp>
@@ -2706,8 +2706,8 @@
         </p:nvSpPr>
         <p:spPr>
           <a:xfrm>
-            <a:off x="502920" y="6492240"/>
-            <a:ext cx="3657600" cy="155448"/>
+            <a:off x="502920" y="6419088"/>
+            <a:ext cx="4389120" cy="256032"/>
           </a:xfrm>
           <a:prstGeom prst="rect">
             <a:avLst/>
@@ -2723,7 +2723,7 @@
               <a:buNone/>
             </a:pPr>
             <a:r>
-              <a:rPr lang="en-US" sz="800" b="1" spc="120" kern="0" dirty="0">
+              <a:rPr lang="en-US" sz="1200" b="1" spc="120" kern="0" dirty="0">
                 <a:solidFill>
                   <a:srgbClr val="65657A"/>
                 </a:solidFill>
@@ -2733,7 +2733,7 @@
               </a:rPr>
               <a:t>SOTECH  /  MUNDO TOURS  /  A</a:t>
             </a:r>
-            <a:endParaRPr lang="en-US" sz="800" dirty="0"/>
+            <a:endParaRPr lang="en-US" sz="1200" dirty="0"/>
           </a:p>
         </p:txBody>
       </p:sp>
@@ -2745,8 +2745,8 @@
         </p:nvSpPr>
         <p:spPr>
           <a:xfrm>
-            <a:off x="11109960" y="6455664"/>
-            <a:ext cx="566928" cy="201168"/>
+            <a:off x="11018520" y="6419088"/>
+            <a:ext cx="658368" cy="256032"/>
           </a:xfrm>
           <a:prstGeom prst="rect">
             <a:avLst/>
@@ -2762,7 +2762,7 @@
               <a:buNone/>
             </a:pPr>
             <a:r>
-              <a:rPr lang="en-US" sz="900" b="1" dirty="0">
+              <a:rPr lang="en-US" sz="1200" b="1" dirty="0">
                 <a:solidFill>
                   <a:srgbClr val="65657A"/>
                 </a:solidFill>
@@ -2772,7 +2772,7 @@
               </a:rPr>
               <a:t>10</a:t>
             </a:r>
-            <a:endParaRPr lang="en-US" sz="900" dirty="0"/>
+            <a:endParaRPr lang="en-US" sz="1200" dirty="0"/>
           </a:p>
         </p:txBody>
       </p:sp>
@@ -3494,8 +3494,8 @@
         </p:nvSpPr>
         <p:spPr>
           <a:xfrm>
-            <a:off x="502920" y="6492240"/>
-            <a:ext cx="3657600" cy="155448"/>
+            <a:off x="502920" y="6419088"/>
+            <a:ext cx="4389120" cy="256032"/>
           </a:xfrm>
           <a:prstGeom prst="rect">
             <a:avLst/>
@@ -3511,7 +3511,7 @@
               <a:buNone/>
             </a:pPr>
             <a:r>
-              <a:rPr lang="en-US" sz="800" b="1" spc="120" kern="0" dirty="0">
+              <a:rPr lang="en-US" sz="1200" b="1" spc="120" kern="0" dirty="0">
                 <a:solidFill>
                   <a:srgbClr val="65657A"/>
                 </a:solidFill>
@@ -3521,7 +3521,7 @@
               </a:rPr>
               <a:t>SOTECH  /  MUNDO TOURS  /  A</a:t>
             </a:r>
-            <a:endParaRPr lang="en-US" sz="800" dirty="0"/>
+            <a:endParaRPr lang="en-US" sz="1200" dirty="0"/>
           </a:p>
         </p:txBody>
       </p:sp>
@@ -3533,8 +3533,8 @@
         </p:nvSpPr>
         <p:spPr>
           <a:xfrm>
-            <a:off x="11109960" y="6455664"/>
-            <a:ext cx="566928" cy="201168"/>
+            <a:off x="11018520" y="6419088"/>
+            <a:ext cx="658368" cy="256032"/>
           </a:xfrm>
           <a:prstGeom prst="rect">
             <a:avLst/>
@@ -3550,7 +3550,7 @@
               <a:buNone/>
             </a:pPr>
             <a:r>
-              <a:rPr lang="en-US" sz="900" b="1" dirty="0">
+              <a:rPr lang="en-US" sz="1200" b="1" dirty="0">
                 <a:solidFill>
                   <a:srgbClr val="65657A"/>
                 </a:solidFill>
@@ -3560,7 +3560,7 @@
               </a:rPr>
               <a:t>11</a:t>
             </a:r>
-            <a:endParaRPr lang="en-US" sz="900" dirty="0"/>
+            <a:endParaRPr lang="en-US" sz="1200" dirty="0"/>
           </a:p>
         </p:txBody>
       </p:sp>
@@ -4186,8 +4186,8 @@
         </p:nvSpPr>
         <p:spPr>
           <a:xfrm>
-            <a:off x="502920" y="6492240"/>
-            <a:ext cx="3657600" cy="155448"/>
+            <a:off x="502920" y="6419088"/>
+            <a:ext cx="4389120" cy="256032"/>
           </a:xfrm>
           <a:prstGeom prst="rect">
             <a:avLst/>
@@ -4203,7 +4203,7 @@
               <a:buNone/>
             </a:pPr>
             <a:r>
-              <a:rPr lang="en-US" sz="800" b="1" spc="120" kern="0" dirty="0">
+              <a:rPr lang="en-US" sz="1200" b="1" spc="120" kern="0" dirty="0">
                 <a:solidFill>
                   <a:srgbClr val="65657A"/>
                 </a:solidFill>
@@ -4213,7 +4213,7 @@
               </a:rPr>
               <a:t>SOTECH  /  MUNDO TOURS  /  A</a:t>
             </a:r>
-            <a:endParaRPr lang="en-US" sz="800" dirty="0"/>
+            <a:endParaRPr lang="en-US" sz="1200" dirty="0"/>
           </a:p>
         </p:txBody>
       </p:sp>
@@ -4225,8 +4225,8 @@
         </p:nvSpPr>
         <p:spPr>
           <a:xfrm>
-            <a:off x="11109960" y="6455664"/>
-            <a:ext cx="566928" cy="201168"/>
+            <a:off x="11018520" y="6419088"/>
+            <a:ext cx="658368" cy="256032"/>
           </a:xfrm>
           <a:prstGeom prst="rect">
             <a:avLst/>
@@ -4242,7 +4242,7 @@
               <a:buNone/>
             </a:pPr>
             <a:r>
-              <a:rPr lang="en-US" sz="900" b="1" dirty="0">
+              <a:rPr lang="en-US" sz="1200" b="1" dirty="0">
                 <a:solidFill>
                   <a:srgbClr val="65657A"/>
                 </a:solidFill>
@@ -4252,7 +4252,7 @@
               </a:rPr>
               <a:t>12</a:t>
             </a:r>
-            <a:endParaRPr lang="en-US" sz="900" dirty="0"/>
+            <a:endParaRPr lang="en-US" sz="1200" dirty="0"/>
           </a:p>
         </p:txBody>
       </p:sp>
@@ -5191,8 +5191,8 @@
         </p:nvSpPr>
         <p:spPr>
           <a:xfrm>
-            <a:off x="502920" y="6492240"/>
-            <a:ext cx="3657600" cy="155448"/>
+            <a:off x="502920" y="6419088"/>
+            <a:ext cx="4389120" cy="256032"/>
           </a:xfrm>
           <a:prstGeom prst="rect">
             <a:avLst/>
@@ -5208,7 +5208,7 @@
               <a:buNone/>
             </a:pPr>
             <a:r>
-              <a:rPr lang="en-US" sz="800" b="1" spc="120" kern="0" dirty="0">
+              <a:rPr lang="en-US" sz="1200" b="1" spc="120" kern="0" dirty="0">
                 <a:solidFill>
                   <a:srgbClr val="65657A"/>
                 </a:solidFill>
@@ -5218,7 +5218,7 @@
               </a:rPr>
               <a:t>SOTECH  /  MUNDO TOURS  /  A</a:t>
             </a:r>
-            <a:endParaRPr lang="en-US" sz="800" dirty="0"/>
+            <a:endParaRPr lang="en-US" sz="1200" dirty="0"/>
           </a:p>
         </p:txBody>
       </p:sp>
@@ -5230,8 +5230,8 @@
         </p:nvSpPr>
         <p:spPr>
           <a:xfrm>
-            <a:off x="11109960" y="6455664"/>
-            <a:ext cx="566928" cy="201168"/>
+            <a:off x="11018520" y="6419088"/>
+            <a:ext cx="658368" cy="256032"/>
           </a:xfrm>
           <a:prstGeom prst="rect">
             <a:avLst/>
@@ -5247,7 +5247,7 @@
               <a:buNone/>
             </a:pPr>
             <a:r>
-              <a:rPr lang="en-US" sz="900" b="1" dirty="0">
+              <a:rPr lang="en-US" sz="1200" b="1" dirty="0">
                 <a:solidFill>
                   <a:srgbClr val="65657A"/>
                 </a:solidFill>
@@ -5257,7 +5257,7 @@
               </a:rPr>
               <a:t>13</a:t>
             </a:r>
-            <a:endParaRPr lang="en-US" sz="900" dirty="0"/>
+            <a:endParaRPr lang="en-US" sz="1200" dirty="0"/>
           </a:p>
         </p:txBody>
       </p:sp>
@@ -5883,8 +5883,8 @@
         </p:nvSpPr>
         <p:spPr>
           <a:xfrm>
-            <a:off x="502920" y="6492240"/>
-            <a:ext cx="3657600" cy="155448"/>
+            <a:off x="502920" y="6419088"/>
+            <a:ext cx="4389120" cy="256032"/>
           </a:xfrm>
           <a:prstGeom prst="rect">
             <a:avLst/>
@@ -5900,7 +5900,7 @@
               <a:buNone/>
             </a:pPr>
             <a:r>
-              <a:rPr lang="en-US" sz="800" b="1" spc="120" kern="0" dirty="0">
+              <a:rPr lang="en-US" sz="1200" b="1" spc="120" kern="0" dirty="0">
                 <a:solidFill>
                   <a:srgbClr val="65657A"/>
                 </a:solidFill>
@@ -5910,7 +5910,7 @@
               </a:rPr>
               <a:t>SOTECH  /  MUNDO TOURS  /  A</a:t>
             </a:r>
-            <a:endParaRPr lang="en-US" sz="800" dirty="0"/>
+            <a:endParaRPr lang="en-US" sz="1200" dirty="0"/>
           </a:p>
         </p:txBody>
       </p:sp>
@@ -5922,8 +5922,8 @@
         </p:nvSpPr>
         <p:spPr>
           <a:xfrm>
-            <a:off x="11109960" y="6455664"/>
-            <a:ext cx="566928" cy="201168"/>
+            <a:off x="11018520" y="6419088"/>
+            <a:ext cx="658368" cy="256032"/>
           </a:xfrm>
           <a:prstGeom prst="rect">
             <a:avLst/>
@@ -5939,7 +5939,7 @@
               <a:buNone/>
             </a:pPr>
             <a:r>
-              <a:rPr lang="en-US" sz="900" b="1" dirty="0">
+              <a:rPr lang="en-US" sz="1200" b="1" dirty="0">
                 <a:solidFill>
                   <a:srgbClr val="65657A"/>
                 </a:solidFill>
@@ -5949,7 +5949,7 @@
               </a:rPr>
               <a:t>14</a:t>
             </a:r>
-            <a:endParaRPr lang="en-US" sz="900" dirty="0"/>
+            <a:endParaRPr lang="en-US" sz="1200" dirty="0"/>
           </a:p>
         </p:txBody>
       </p:sp>
@@ -6658,8 +6658,8 @@
         </p:nvSpPr>
         <p:spPr>
           <a:xfrm>
-            <a:off x="502920" y="6492240"/>
-            <a:ext cx="3657600" cy="155448"/>
+            <a:off x="502920" y="6419088"/>
+            <a:ext cx="4389120" cy="256032"/>
           </a:xfrm>
           <a:prstGeom prst="rect">
             <a:avLst/>
@@ -6675,7 +6675,7 @@
               <a:buNone/>
             </a:pPr>
             <a:r>
-              <a:rPr lang="en-US" sz="800" b="1" spc="120" kern="0" dirty="0">
+              <a:rPr lang="en-US" sz="1200" b="1" spc="120" kern="0" dirty="0">
                 <a:solidFill>
                   <a:srgbClr val="65657A"/>
                 </a:solidFill>
@@ -6685,7 +6685,7 @@
               </a:rPr>
               <a:t>SOTECH  /  MUNDO TOURS  /  A</a:t>
             </a:r>
-            <a:endParaRPr lang="en-US" sz="800" dirty="0"/>
+            <a:endParaRPr lang="en-US" sz="1200" dirty="0"/>
           </a:p>
         </p:txBody>
       </p:sp>
@@ -6697,8 +6697,8 @@
         </p:nvSpPr>
         <p:spPr>
           <a:xfrm>
-            <a:off x="11109960" y="6455664"/>
-            <a:ext cx="566928" cy="201168"/>
+            <a:off x="11018520" y="6419088"/>
+            <a:ext cx="658368" cy="256032"/>
           </a:xfrm>
           <a:prstGeom prst="rect">
             <a:avLst/>
@@ -6714,7 +6714,7 @@
               <a:buNone/>
             </a:pPr>
             <a:r>
-              <a:rPr lang="en-US" sz="900" b="1" dirty="0">
+              <a:rPr lang="en-US" sz="1200" b="1" dirty="0">
                 <a:solidFill>
                   <a:srgbClr val="65657A"/>
                 </a:solidFill>
@@ -6724,7 +6724,7 @@
               </a:rPr>
               <a:t>15</a:t>
             </a:r>
-            <a:endParaRPr lang="en-US" sz="900" dirty="0"/>
+            <a:endParaRPr lang="en-US" sz="1200" dirty="0"/>
           </a:p>
         </p:txBody>
       </p:sp>
@@ -7323,8 +7323,8 @@
         </p:nvSpPr>
         <p:spPr>
           <a:xfrm>
-            <a:off x="502920" y="6492240"/>
-            <a:ext cx="3657600" cy="155448"/>
+            <a:off x="502920" y="6419088"/>
+            <a:ext cx="4389120" cy="256032"/>
           </a:xfrm>
           <a:prstGeom prst="rect">
             <a:avLst/>
@@ -7340,7 +7340,7 @@
               <a:buNone/>
             </a:pPr>
             <a:r>
-              <a:rPr lang="en-US" sz="800" b="1" spc="120" kern="0" dirty="0">
+              <a:rPr lang="en-US" sz="1200" b="1" spc="120" kern="0" dirty="0">
                 <a:solidFill>
                   <a:srgbClr val="65657A"/>
                 </a:solidFill>
@@ -7350,7 +7350,7 @@
               </a:rPr>
               <a:t>SOTECH  /  MUNDO TOURS  /  A</a:t>
             </a:r>
-            <a:endParaRPr lang="en-US" sz="800" dirty="0"/>
+            <a:endParaRPr lang="en-US" sz="1200" dirty="0"/>
           </a:p>
         </p:txBody>
       </p:sp>
@@ -7362,8 +7362,8 @@
         </p:nvSpPr>
         <p:spPr>
           <a:xfrm>
-            <a:off x="11109960" y="6455664"/>
-            <a:ext cx="566928" cy="201168"/>
+            <a:off x="11018520" y="6419088"/>
+            <a:ext cx="658368" cy="256032"/>
           </a:xfrm>
           <a:prstGeom prst="rect">
             <a:avLst/>
@@ -7379,7 +7379,7 @@
               <a:buNone/>
             </a:pPr>
             <a:r>
-              <a:rPr lang="en-US" sz="900" b="1" dirty="0">
+              <a:rPr lang="en-US" sz="1200" b="1" dirty="0">
                 <a:solidFill>
                   <a:srgbClr val="65657A"/>
                 </a:solidFill>
@@ -7389,7 +7389,7 @@
               </a:rPr>
               <a:t>16</a:t>
             </a:r>
-            <a:endParaRPr lang="en-US" sz="900" dirty="0"/>
+            <a:endParaRPr lang="en-US" sz="1200" dirty="0"/>
           </a:p>
         </p:txBody>
       </p:sp>
@@ -7794,7 +7794,7 @@
                 <a:ea typeface="Aptos" pitchFamily="34" charset="-122"/>
                 <a:cs typeface="Aptos" pitchFamily="34" charset="-120"/>
               </a:rPr>
-              <a:t>English staging site and analytics / CRM readiness</a:t>
+              <a:t>Keyword demand and volume data are limited and not independently verified</a:t>
             </a:r>
             <a:endParaRPr lang="en-US" sz="1400" dirty="0"/>
           </a:p>
@@ -7903,7 +7903,7 @@
                 <a:ea typeface="Aptos" pitchFamily="34" charset="-122"/>
                 <a:cs typeface="Aptos" pitchFamily="34" charset="-120"/>
               </a:rPr>
-              <a:t>Local Houston advantage and accountable sales ownership</a:t>
+              <a:t>English staging site and analytics / CRM readiness</a:t>
             </a:r>
             <a:endParaRPr lang="en-US" sz="1400" dirty="0"/>
           </a:p>
@@ -7986,6 +7986,115 @@
         <p:spPr>
           <a:xfrm>
             <a:off x="2011680" y="4782312"/>
+            <a:ext cx="9144000" cy="347472"/>
+          </a:xfrm>
+          <a:prstGeom prst="rect">
+            <a:avLst/>
+          </a:prstGeom>
+          <a:noFill/>
+          <a:ln/>
+        </p:spPr>
+        <p:txBody>
+          <a:bodyPr wrap="square" lIns="0" tIns="0" rIns="0" bIns="0" rtlCol="0" anchor="ctr">
+            <a:normAutofit/>
+          </a:bodyPr>
+          <a:lstStyle/>
+          <a:p>
+            <a:pPr indent="0" marL="0">
+              <a:buNone/>
+            </a:pPr>
+            <a:r>
+              <a:rPr lang="en-US" sz="1400" dirty="0">
+                <a:solidFill>
+                  <a:srgbClr val="14143A"/>
+                </a:solidFill>
+                <a:latin typeface="Aptos" pitchFamily="34" charset="0"/>
+                <a:ea typeface="Aptos" pitchFamily="34" charset="-122"/>
+                <a:cs typeface="Aptos" pitchFamily="34" charset="-120"/>
+              </a:rPr>
+              <a:t>Local Houston advantage and accountable sales ownership</a:t>
+            </a:r>
+            <a:endParaRPr lang="en-US" sz="1400" dirty="0"/>
+          </a:p>
+        </p:txBody>
+      </p:sp>
+      <p:sp>
+        <p:nvSpPr>
+          <p:cNvPr id="22" name="Shape 20"/>
+          <p:cNvSpPr/>
+          <p:nvPr/>
+        </p:nvSpPr>
+        <p:spPr>
+          <a:xfrm>
+            <a:off x="731520" y="5486400"/>
+            <a:ext cx="1005840" cy="457200"/>
+          </a:xfrm>
+          <a:prstGeom prst="roundRect">
+            <a:avLst>
+              <a:gd name="adj" fmla="val 24000"/>
+            </a:avLst>
+          </a:prstGeom>
+          <a:solidFill>
+            <a:srgbClr val="E2A84A"/>
+          </a:solidFill>
+          <a:ln w="12700">
+            <a:solidFill>
+              <a:srgbClr val="E2A84A"/>
+            </a:solidFill>
+            <a:prstDash val="solid"/>
+          </a:ln>
+        </p:spPr>
+      </p:sp>
+      <p:sp>
+        <p:nvSpPr>
+          <p:cNvPr id="23" name="Text 21"/>
+          <p:cNvSpPr/>
+          <p:nvPr/>
+        </p:nvSpPr>
+        <p:spPr>
+          <a:xfrm>
+            <a:off x="822960" y="5596128"/>
+            <a:ext cx="822960" cy="182880"/>
+          </a:xfrm>
+          <a:prstGeom prst="rect">
+            <a:avLst/>
+          </a:prstGeom>
+          <a:noFill/>
+          <a:ln/>
+        </p:spPr>
+        <p:txBody>
+          <a:bodyPr wrap="square" lIns="0" tIns="0" rIns="0" bIns="0" rtlCol="0" anchor="ctr">
+            <a:normAutofit/>
+          </a:bodyPr>
+          <a:lstStyle/>
+          <a:p>
+            <a:pPr algn="ctr" indent="0" marL="0">
+              <a:buNone/>
+            </a:pPr>
+            <a:r>
+              <a:rPr lang="en-US" sz="1000" b="1" dirty="0">
+                <a:solidFill>
+                  <a:srgbClr val="FFFFFF"/>
+                </a:solidFill>
+                <a:latin typeface="Aptos" pitchFamily="34" charset="0"/>
+                <a:ea typeface="Aptos" pitchFamily="34" charset="-122"/>
+                <a:cs typeface="Aptos" pitchFamily="34" charset="-120"/>
+              </a:rPr>
+              <a:t>Medium</a:t>
+            </a:r>
+            <a:endParaRPr lang="en-US" sz="1000" dirty="0"/>
+          </a:p>
+        </p:txBody>
+      </p:sp>
+      <p:sp>
+        <p:nvSpPr>
+          <p:cNvPr id="24" name="Text 22"/>
+          <p:cNvSpPr/>
+          <p:nvPr/>
+        </p:nvSpPr>
+        <p:spPr>
+          <a:xfrm>
+            <a:off x="2011680" y="5513832"/>
             <a:ext cx="9144000" cy="347472"/>
           </a:xfrm>
           <a:prstGeom prst="rect">
@@ -8083,8 +8192,8 @@
         </p:nvSpPr>
         <p:spPr>
           <a:xfrm>
-            <a:off x="502920" y="6492240"/>
-            <a:ext cx="3657600" cy="155448"/>
+            <a:off x="502920" y="6419088"/>
+            <a:ext cx="4389120" cy="256032"/>
           </a:xfrm>
           <a:prstGeom prst="rect">
             <a:avLst/>
@@ -8100,7 +8209,7 @@
               <a:buNone/>
             </a:pPr>
             <a:r>
-              <a:rPr lang="en-US" sz="800" b="1" spc="120" kern="0" dirty="0">
+              <a:rPr lang="en-US" sz="1200" b="1" spc="120" kern="0" dirty="0">
                 <a:solidFill>
                   <a:srgbClr val="B3B3FF"/>
                 </a:solidFill>
@@ -8110,7 +8219,7 @@
               </a:rPr>
               <a:t>SOTECH  /  MUNDO TOURS  /  A</a:t>
             </a:r>
-            <a:endParaRPr lang="en-US" sz="800" dirty="0"/>
+            <a:endParaRPr lang="en-US" sz="1200" dirty="0"/>
           </a:p>
         </p:txBody>
       </p:sp>
@@ -8122,8 +8231,8 @@
         </p:nvSpPr>
         <p:spPr>
           <a:xfrm>
-            <a:off x="11109960" y="6455664"/>
-            <a:ext cx="566928" cy="201168"/>
+            <a:off x="11018520" y="6419088"/>
+            <a:ext cx="658368" cy="256032"/>
           </a:xfrm>
           <a:prstGeom prst="rect">
             <a:avLst/>
@@ -8139,7 +8248,7 @@
               <a:buNone/>
             </a:pPr>
             <a:r>
-              <a:rPr lang="en-US" sz="900" b="1" dirty="0">
+              <a:rPr lang="en-US" sz="1200" b="1" dirty="0">
                 <a:solidFill>
                   <a:srgbClr val="B3B3FF"/>
                 </a:solidFill>
@@ -8149,7 +8258,7 @@
               </a:rPr>
               <a:t>17</a:t>
             </a:r>
-            <a:endParaRPr lang="en-US" sz="900" dirty="0"/>
+            <a:endParaRPr lang="en-US" sz="1200" dirty="0"/>
           </a:p>
         </p:txBody>
       </p:sp>
@@ -8993,8 +9102,8 @@
         </p:nvSpPr>
         <p:spPr>
           <a:xfrm>
-            <a:off x="502920" y="6492240"/>
-            <a:ext cx="3657600" cy="155448"/>
+            <a:off x="502920" y="6419088"/>
+            <a:ext cx="4389120" cy="256032"/>
           </a:xfrm>
           <a:prstGeom prst="rect">
             <a:avLst/>
@@ -9010,7 +9119,7 @@
               <a:buNone/>
             </a:pPr>
             <a:r>
-              <a:rPr lang="en-US" sz="800" b="1" spc="120" kern="0" dirty="0">
+              <a:rPr lang="en-US" sz="1200" b="1" spc="120" kern="0" dirty="0">
                 <a:solidFill>
                   <a:srgbClr val="B3B3FF"/>
                 </a:solidFill>
@@ -9020,7 +9129,7 @@
               </a:rPr>
               <a:t>SOTECH  /  MUNDO TOURS  /  A</a:t>
             </a:r>
-            <a:endParaRPr lang="en-US" sz="800" dirty="0"/>
+            <a:endParaRPr lang="en-US" sz="1200" dirty="0"/>
           </a:p>
         </p:txBody>
       </p:sp>
@@ -9032,8 +9141,8 @@
         </p:nvSpPr>
         <p:spPr>
           <a:xfrm>
-            <a:off x="11109960" y="6455664"/>
-            <a:ext cx="566928" cy="201168"/>
+            <a:off x="11018520" y="6419088"/>
+            <a:ext cx="658368" cy="256032"/>
           </a:xfrm>
           <a:prstGeom prst="rect">
             <a:avLst/>
@@ -9049,7 +9158,7 @@
               <a:buNone/>
             </a:pPr>
             <a:r>
-              <a:rPr lang="en-US" sz="900" b="1" dirty="0">
+              <a:rPr lang="en-US" sz="1200" b="1" dirty="0">
                 <a:solidFill>
                   <a:srgbClr val="B3B3FF"/>
                 </a:solidFill>
@@ -9059,7 +9168,7 @@
               </a:rPr>
               <a:t>02</a:t>
             </a:r>
-            <a:endParaRPr lang="en-US" sz="900" dirty="0"/>
+            <a:endParaRPr lang="en-US" sz="1200" dirty="0"/>
           </a:p>
         </p:txBody>
       </p:sp>
@@ -9535,8 +9644,8 @@
         </p:nvSpPr>
         <p:spPr>
           <a:xfrm>
-            <a:off x="502920" y="6492240"/>
-            <a:ext cx="3657600" cy="155448"/>
+            <a:off x="502920" y="6419088"/>
+            <a:ext cx="4389120" cy="256032"/>
           </a:xfrm>
           <a:prstGeom prst="rect">
             <a:avLst/>
@@ -9552,7 +9661,7 @@
               <a:buNone/>
             </a:pPr>
             <a:r>
-              <a:rPr lang="en-US" sz="800" b="1" spc="120" kern="0" dirty="0">
+              <a:rPr lang="en-US" sz="1200" b="1" spc="120" kern="0" dirty="0">
                 <a:solidFill>
                   <a:srgbClr val="65657A"/>
                 </a:solidFill>
@@ -9562,7 +9671,7 @@
               </a:rPr>
               <a:t>SOTECH  /  MUNDO TOURS  /  A</a:t>
             </a:r>
-            <a:endParaRPr lang="en-US" sz="800" dirty="0"/>
+            <a:endParaRPr lang="en-US" sz="1200" dirty="0"/>
           </a:p>
         </p:txBody>
       </p:sp>
@@ -9574,8 +9683,8 @@
         </p:nvSpPr>
         <p:spPr>
           <a:xfrm>
-            <a:off x="11109960" y="6455664"/>
-            <a:ext cx="566928" cy="201168"/>
+            <a:off x="11018520" y="6419088"/>
+            <a:ext cx="658368" cy="256032"/>
           </a:xfrm>
           <a:prstGeom prst="rect">
             <a:avLst/>
@@ -9591,7 +9700,7 @@
               <a:buNone/>
             </a:pPr>
             <a:r>
-              <a:rPr lang="en-US" sz="900" b="1" dirty="0">
+              <a:rPr lang="en-US" sz="1200" b="1" dirty="0">
                 <a:solidFill>
                   <a:srgbClr val="65657A"/>
                 </a:solidFill>
@@ -9601,7 +9710,7 @@
               </a:rPr>
               <a:t>03</a:t>
             </a:r>
-            <a:endParaRPr lang="en-US" sz="900" dirty="0"/>
+            <a:endParaRPr lang="en-US" sz="1200" dirty="0"/>
           </a:p>
         </p:txBody>
       </p:sp>
@@ -10473,8 +10582,8 @@
         </p:nvSpPr>
         <p:spPr>
           <a:xfrm>
-            <a:off x="502920" y="6492240"/>
-            <a:ext cx="3657600" cy="155448"/>
+            <a:off x="502920" y="6419088"/>
+            <a:ext cx="4389120" cy="256032"/>
           </a:xfrm>
           <a:prstGeom prst="rect">
             <a:avLst/>
@@ -10490,7 +10599,7 @@
               <a:buNone/>
             </a:pPr>
             <a:r>
-              <a:rPr lang="en-US" sz="800" b="1" spc="120" kern="0" dirty="0">
+              <a:rPr lang="en-US" sz="1200" b="1" spc="120" kern="0" dirty="0">
                 <a:solidFill>
                   <a:srgbClr val="65657A"/>
                 </a:solidFill>
@@ -10500,7 +10609,7 @@
               </a:rPr>
               <a:t>SOTECH  /  MUNDO TOURS  /  A</a:t>
             </a:r>
-            <a:endParaRPr lang="en-US" sz="800" dirty="0"/>
+            <a:endParaRPr lang="en-US" sz="1200" dirty="0"/>
           </a:p>
         </p:txBody>
       </p:sp>
@@ -10512,8 +10621,8 @@
         </p:nvSpPr>
         <p:spPr>
           <a:xfrm>
-            <a:off x="11109960" y="6455664"/>
-            <a:ext cx="566928" cy="201168"/>
+            <a:off x="11018520" y="6419088"/>
+            <a:ext cx="658368" cy="256032"/>
           </a:xfrm>
           <a:prstGeom prst="rect">
             <a:avLst/>
@@ -10529,7 +10638,7 @@
               <a:buNone/>
             </a:pPr>
             <a:r>
-              <a:rPr lang="en-US" sz="900" b="1" dirty="0">
+              <a:rPr lang="en-US" sz="1200" b="1" dirty="0">
                 <a:solidFill>
                   <a:srgbClr val="65657A"/>
                 </a:solidFill>
@@ -10539,7 +10648,7 @@
               </a:rPr>
               <a:t>04</a:t>
             </a:r>
-            <a:endParaRPr lang="en-US" sz="900" dirty="0"/>
+            <a:endParaRPr lang="en-US" sz="1200" dirty="0"/>
           </a:p>
         </p:txBody>
       </p:sp>
@@ -11165,8 +11274,8 @@
         </p:nvSpPr>
         <p:spPr>
           <a:xfrm>
-            <a:off x="502920" y="6492240"/>
-            <a:ext cx="3657600" cy="155448"/>
+            <a:off x="502920" y="6419088"/>
+            <a:ext cx="4389120" cy="256032"/>
           </a:xfrm>
           <a:prstGeom prst="rect">
             <a:avLst/>
@@ -11182,7 +11291,7 @@
               <a:buNone/>
             </a:pPr>
             <a:r>
-              <a:rPr lang="en-US" sz="800" b="1" spc="120" kern="0" dirty="0">
+              <a:rPr lang="en-US" sz="1200" b="1" spc="120" kern="0" dirty="0">
                 <a:solidFill>
                   <a:srgbClr val="65657A"/>
                 </a:solidFill>
@@ -11192,7 +11301,7 @@
               </a:rPr>
               <a:t>SOTECH  /  MUNDO TOURS  /  A</a:t>
             </a:r>
-            <a:endParaRPr lang="en-US" sz="800" dirty="0"/>
+            <a:endParaRPr lang="en-US" sz="1200" dirty="0"/>
           </a:p>
         </p:txBody>
       </p:sp>
@@ -11204,8 +11313,8 @@
         </p:nvSpPr>
         <p:spPr>
           <a:xfrm>
-            <a:off x="11109960" y="6455664"/>
-            <a:ext cx="566928" cy="201168"/>
+            <a:off x="11018520" y="6419088"/>
+            <a:ext cx="658368" cy="256032"/>
           </a:xfrm>
           <a:prstGeom prst="rect">
             <a:avLst/>
@@ -11221,7 +11330,7 @@
               <a:buNone/>
             </a:pPr>
             <a:r>
-              <a:rPr lang="en-US" sz="900" b="1" dirty="0">
+              <a:rPr lang="en-US" sz="1200" b="1" dirty="0">
                 <a:solidFill>
                   <a:srgbClr val="65657A"/>
                 </a:solidFill>
@@ -11231,7 +11340,7 @@
               </a:rPr>
               <a:t>05</a:t>
             </a:r>
-            <a:endParaRPr lang="en-US" sz="900" dirty="0"/>
+            <a:endParaRPr lang="en-US" sz="1200" dirty="0"/>
           </a:p>
         </p:txBody>
       </p:sp>
@@ -12172,8 +12281,8 @@
         </p:nvSpPr>
         <p:spPr>
           <a:xfrm>
-            <a:off x="502920" y="6492240"/>
-            <a:ext cx="3657600" cy="155448"/>
+            <a:off x="502920" y="6419088"/>
+            <a:ext cx="4389120" cy="256032"/>
           </a:xfrm>
           <a:prstGeom prst="rect">
             <a:avLst/>
@@ -12189,7 +12298,7 @@
               <a:buNone/>
             </a:pPr>
             <a:r>
-              <a:rPr lang="en-US" sz="800" b="1" spc="120" kern="0" dirty="0">
+              <a:rPr lang="en-US" sz="1200" b="1" spc="120" kern="0" dirty="0">
                 <a:solidFill>
                   <a:srgbClr val="65657A"/>
                 </a:solidFill>
@@ -12199,7 +12308,7 @@
               </a:rPr>
               <a:t>SOTECH  /  MUNDO TOURS  /  A</a:t>
             </a:r>
-            <a:endParaRPr lang="en-US" sz="800" dirty="0"/>
+            <a:endParaRPr lang="en-US" sz="1200" dirty="0"/>
           </a:p>
         </p:txBody>
       </p:sp>
@@ -12211,8 +12320,8 @@
         </p:nvSpPr>
         <p:spPr>
           <a:xfrm>
-            <a:off x="11109960" y="6455664"/>
-            <a:ext cx="566928" cy="201168"/>
+            <a:off x="11018520" y="6419088"/>
+            <a:ext cx="658368" cy="256032"/>
           </a:xfrm>
           <a:prstGeom prst="rect">
             <a:avLst/>
@@ -12228,7 +12337,7 @@
               <a:buNone/>
             </a:pPr>
             <a:r>
-              <a:rPr lang="en-US" sz="900" b="1" dirty="0">
+              <a:rPr lang="en-US" sz="1200" b="1" dirty="0">
                 <a:solidFill>
                   <a:srgbClr val="65657A"/>
                 </a:solidFill>
@@ -12238,7 +12347,7 @@
               </a:rPr>
               <a:t>06</a:t>
             </a:r>
-            <a:endParaRPr lang="en-US" sz="900" dirty="0"/>
+            <a:endParaRPr lang="en-US" sz="1200" dirty="0"/>
           </a:p>
         </p:txBody>
       </p:sp>
@@ -12755,8 +12864,8 @@
         </p:nvSpPr>
         <p:spPr>
           <a:xfrm>
-            <a:off x="502920" y="6492240"/>
-            <a:ext cx="3657600" cy="155448"/>
+            <a:off x="502920" y="6419088"/>
+            <a:ext cx="4389120" cy="256032"/>
           </a:xfrm>
           <a:prstGeom prst="rect">
             <a:avLst/>
@@ -12772,7 +12881,7 @@
               <a:buNone/>
             </a:pPr>
             <a:r>
-              <a:rPr lang="en-US" sz="800" b="1" spc="120" kern="0" dirty="0">
+              <a:rPr lang="en-US" sz="1200" b="1" spc="120" kern="0" dirty="0">
                 <a:solidFill>
                   <a:srgbClr val="65657A"/>
                 </a:solidFill>
@@ -12782,7 +12891,7 @@
               </a:rPr>
               <a:t>SOTECH  /  MUNDO TOURS  /  A</a:t>
             </a:r>
-            <a:endParaRPr lang="en-US" sz="800" dirty="0"/>
+            <a:endParaRPr lang="en-US" sz="1200" dirty="0"/>
           </a:p>
         </p:txBody>
       </p:sp>
@@ -12794,8 +12903,8 @@
         </p:nvSpPr>
         <p:spPr>
           <a:xfrm>
-            <a:off x="11109960" y="6455664"/>
-            <a:ext cx="566928" cy="201168"/>
+            <a:off x="11018520" y="6419088"/>
+            <a:ext cx="658368" cy="256032"/>
           </a:xfrm>
           <a:prstGeom prst="rect">
             <a:avLst/>
@@ -12811,7 +12920,7 @@
               <a:buNone/>
             </a:pPr>
             <a:r>
-              <a:rPr lang="en-US" sz="900" b="1" dirty="0">
+              <a:rPr lang="en-US" sz="1200" b="1" dirty="0">
                 <a:solidFill>
                   <a:srgbClr val="65657A"/>
                 </a:solidFill>
@@ -12821,7 +12930,7 @@
               </a:rPr>
               <a:t>07</a:t>
             </a:r>
-            <a:endParaRPr lang="en-US" sz="900" dirty="0"/>
+            <a:endParaRPr lang="en-US" sz="1200" dirty="0"/>
           </a:p>
         </p:txBody>
       </p:sp>
@@ -13665,8 +13774,8 @@
         </p:nvSpPr>
         <p:spPr>
           <a:xfrm>
-            <a:off x="502920" y="6492240"/>
-            <a:ext cx="3657600" cy="155448"/>
+            <a:off x="502920" y="6419088"/>
+            <a:ext cx="4389120" cy="256032"/>
           </a:xfrm>
           <a:prstGeom prst="rect">
             <a:avLst/>
@@ -13682,7 +13791,7 @@
               <a:buNone/>
             </a:pPr>
             <a:r>
-              <a:rPr lang="en-US" sz="800" b="1" spc="120" kern="0" dirty="0">
+              <a:rPr lang="en-US" sz="1200" b="1" spc="120" kern="0" dirty="0">
                 <a:solidFill>
                   <a:srgbClr val="65657A"/>
                 </a:solidFill>
@@ -13692,7 +13801,7 @@
               </a:rPr>
               <a:t>SOTECH  /  MUNDO TOURS  /  A</a:t>
             </a:r>
-            <a:endParaRPr lang="en-US" sz="800" dirty="0"/>
+            <a:endParaRPr lang="en-US" sz="1200" dirty="0"/>
           </a:p>
         </p:txBody>
       </p:sp>
@@ -13704,8 +13813,8 @@
         </p:nvSpPr>
         <p:spPr>
           <a:xfrm>
-            <a:off x="11109960" y="6455664"/>
-            <a:ext cx="566928" cy="201168"/>
+            <a:off x="11018520" y="6419088"/>
+            <a:ext cx="658368" cy="256032"/>
           </a:xfrm>
           <a:prstGeom prst="rect">
             <a:avLst/>
@@ -13721,7 +13830,7 @@
               <a:buNone/>
             </a:pPr>
             <a:r>
-              <a:rPr lang="en-US" sz="900" b="1" dirty="0">
+              <a:rPr lang="en-US" sz="1200" b="1" dirty="0">
                 <a:solidFill>
                   <a:srgbClr val="65657A"/>
                 </a:solidFill>
@@ -13731,7 +13840,7 @@
               </a:rPr>
               <a:t>08</a:t>
             </a:r>
-            <a:endParaRPr lang="en-US" sz="900" dirty="0"/>
+            <a:endParaRPr lang="en-US" sz="1200" dirty="0"/>
           </a:p>
         </p:txBody>
       </p:sp>
@@ -14374,8 +14483,8 @@
         </p:nvSpPr>
         <p:spPr>
           <a:xfrm>
-            <a:off x="502920" y="6492240"/>
-            <a:ext cx="3657600" cy="155448"/>
+            <a:off x="502920" y="6419088"/>
+            <a:ext cx="4389120" cy="256032"/>
           </a:xfrm>
           <a:prstGeom prst="rect">
             <a:avLst/>
@@ -14391,7 +14500,7 @@
               <a:buNone/>
             </a:pPr>
             <a:r>
-              <a:rPr lang="en-US" sz="800" b="1" spc="120" kern="0" dirty="0">
+              <a:rPr lang="en-US" sz="1200" b="1" spc="120" kern="0" dirty="0">
                 <a:solidFill>
                   <a:srgbClr val="65657A"/>
                 </a:solidFill>
@@ -14401,7 +14510,7 @@
               </a:rPr>
               <a:t>SOTECH  /  MUNDO TOURS  /  A</a:t>
             </a:r>
-            <a:endParaRPr lang="en-US" sz="800" dirty="0"/>
+            <a:endParaRPr lang="en-US" sz="1200" dirty="0"/>
           </a:p>
         </p:txBody>
       </p:sp>
@@ -14413,8 +14522,8 @@
         </p:nvSpPr>
         <p:spPr>
           <a:xfrm>
-            <a:off x="11109960" y="6455664"/>
-            <a:ext cx="566928" cy="201168"/>
+            <a:off x="11018520" y="6419088"/>
+            <a:ext cx="658368" cy="256032"/>
           </a:xfrm>
           <a:prstGeom prst="rect">
             <a:avLst/>
@@ -14430,7 +14539,7 @@
               <a:buNone/>
             </a:pPr>
             <a:r>
-              <a:rPr lang="en-US" sz="900" b="1" dirty="0">
+              <a:rPr lang="en-US" sz="1200" b="1" dirty="0">
                 <a:solidFill>
                   <a:srgbClr val="65657A"/>
                 </a:solidFill>
@@ -14440,7 +14549,7 @@
               </a:rPr>
               <a:t>09</a:t>
             </a:r>
-            <a:endParaRPr lang="en-US" sz="900" dirty="0"/>
+            <a:endParaRPr lang="en-US" sz="1200" dirty="0"/>
           </a:p>
         </p:txBody>
       </p:sp>

</xml_diff>